<commit_message>
Match Origa role-load table to the CKO roadmap slide.
Same seven roles and columns (план / закрыто / осталось / финиш); merge back+front into Разработка ЦКО.

Co-authored-by: bbenicore-web <bbenicore-web@users.noreply.github.com>
</commit_message>
<xml_diff>
--- a/status/Origa_status_20-08.pptx
+++ b/status/Origa_status_20-08.pptx
@@ -8,7 +8,7 @@
     <p:sldId id="256" r:id="rId7"/>
     <p:sldId id="257" r:id="rId8"/>
   </p:sldIdLst>
-  <p:sldSz cx="12191999" cy="6858000" type="screen4x3"/>
+  <p:sldSz cx="12192000" cy="6858000" type="screen4x3"/>
   <p:notesSz cx="6858000" cy="9144000"/>
   <p:defaultTextStyle>
     <a:defPPr>
@@ -3106,7 +3106,7 @@
         <p:spPr>
           <a:xfrm>
             <a:off x="0" y="0"/>
-            <a:ext cx="12191999" cy="6858000"/>
+            <a:ext cx="12192000" cy="6858000"/>
           </a:xfrm>
           <a:prstGeom prst="rect">
             <a:avLst/>
@@ -3148,7 +3148,7 @@
         <p:spPr>
           <a:xfrm>
             <a:off x="0" y="0"/>
-            <a:ext cx="12191999" cy="6858000"/>
+            <a:ext cx="12192000" cy="6858000"/>
           </a:xfrm>
           <a:prstGeom prst="rect">
             <a:avLst/>

</xml_diff>

<commit_message>
Add an Origa slide unpacking the general preparation workstream.
Same v_2 timeline format: ШПК, design, pricing, CJ, contact center, and the rest of Общее.

Co-authored-by: bbenicore-web <bbenicore-web@users.noreply.github.com>
</commit_message>
<xml_diff>
--- a/status/Origa_status_20-08.pptx
+++ b/status/Origa_status_20-08.pptx
@@ -7,6 +7,7 @@
   <p:sldIdLst>
     <p:sldId id="256" r:id="rId7"/>
     <p:sldId id="257" r:id="rId8"/>
+    <p:sldId id="258" r:id="rId9"/>
   </p:sldIdLst>
   <p:sldSz cx="12192000" cy="6858000" type="screen4x3"/>
   <p:notesSz cx="6858000" cy="9144000"/>
@@ -3122,6 +3123,48 @@
 </file>
 
 <file path=ppt/slides/slide2.xml><?xml version="1.0" encoding="utf-8"?>
+<p:sld xmlns:a="http://schemas.openxmlformats.org/drawingml/2006/main" xmlns:p="http://schemas.openxmlformats.org/presentationml/2006/main" xmlns:r="http://schemas.openxmlformats.org/officeDocument/2006/relationships">
+  <p:cSld>
+    <p:spTree>
+      <p:nvGrpSpPr>
+        <p:cNvPr id="1" name=""/>
+        <p:cNvGrpSpPr/>
+        <p:nvPr/>
+      </p:nvGrpSpPr>
+      <p:grpSpPr/>
+      <p:pic>
+        <p:nvPicPr>
+          <p:cNvPr id="2" name="Picture 1" descr="slide_general.png"/>
+          <p:cNvPicPr>
+            <a:picLocks noChangeAspect="1"/>
+          </p:cNvPicPr>
+          <p:nvPr/>
+        </p:nvPicPr>
+        <p:blipFill>
+          <a:blip r:embed="rId2"/>
+          <a:stretch>
+            <a:fillRect/>
+          </a:stretch>
+        </p:blipFill>
+        <p:spPr>
+          <a:xfrm>
+            <a:off x="0" y="0"/>
+            <a:ext cx="12192000" cy="6858000"/>
+          </a:xfrm>
+          <a:prstGeom prst="rect">
+            <a:avLst/>
+          </a:prstGeom>
+        </p:spPr>
+      </p:pic>
+    </p:spTree>
+  </p:cSld>
+  <p:clrMapOvr>
+    <a:masterClrMapping/>
+  </p:clrMapOvr>
+</p:sld>
+</file>
+
+<file path=ppt/slides/slide3.xml><?xml version="1.0" encoding="utf-8"?>
 <p:sld xmlns:a="http://schemas.openxmlformats.org/drawingml/2006/main" xmlns:p="http://schemas.openxmlformats.org/presentationml/2006/main" xmlns:r="http://schemas.openxmlformats.org/officeDocument/2006/relationships">
   <p:cSld>
     <p:spTree>

</xml_diff>

<commit_message>
Drop the extra Origa preparation slide.
Keep the two-slide deck: role load and the program timeline from the v_2 template.

Co-authored-by: bbenicore-web <bbenicore-web@users.noreply.github.com>
</commit_message>
<xml_diff>
--- a/status/Origa_status_20-08.pptx
+++ b/status/Origa_status_20-08.pptx
@@ -7,7 +7,6 @@
   <p:sldIdLst>
     <p:sldId id="256" r:id="rId7"/>
     <p:sldId id="257" r:id="rId8"/>
-    <p:sldId id="258" r:id="rId9"/>
   </p:sldIdLst>
   <p:sldSz cx="12192000" cy="6858000" type="screen4x3"/>
   <p:notesSz cx="6858000" cy="9144000"/>
@@ -3123,48 +3122,6 @@
 </file>
 
 <file path=ppt/slides/slide2.xml><?xml version="1.0" encoding="utf-8"?>
-<p:sld xmlns:a="http://schemas.openxmlformats.org/drawingml/2006/main" xmlns:p="http://schemas.openxmlformats.org/presentationml/2006/main" xmlns:r="http://schemas.openxmlformats.org/officeDocument/2006/relationships">
-  <p:cSld>
-    <p:spTree>
-      <p:nvGrpSpPr>
-        <p:cNvPr id="1" name=""/>
-        <p:cNvGrpSpPr/>
-        <p:nvPr/>
-      </p:nvGrpSpPr>
-      <p:grpSpPr/>
-      <p:pic>
-        <p:nvPicPr>
-          <p:cNvPr id="2" name="Picture 1" descr="slide_general.png"/>
-          <p:cNvPicPr>
-            <a:picLocks noChangeAspect="1"/>
-          </p:cNvPicPr>
-          <p:nvPr/>
-        </p:nvPicPr>
-        <p:blipFill>
-          <a:blip r:embed="rId2"/>
-          <a:stretch>
-            <a:fillRect/>
-          </a:stretch>
-        </p:blipFill>
-        <p:spPr>
-          <a:xfrm>
-            <a:off x="0" y="0"/>
-            <a:ext cx="12192000" cy="6858000"/>
-          </a:xfrm>
-          <a:prstGeom prst="rect">
-            <a:avLst/>
-          </a:prstGeom>
-        </p:spPr>
-      </p:pic>
-    </p:spTree>
-  </p:cSld>
-  <p:clrMapOvr>
-    <a:masterClrMapping/>
-  </p:clrMapOvr>
-</p:sld>
-</file>
-
-<file path=ppt/slides/slide3.xml><?xml version="1.0" encoding="utf-8"?>
 <p:sld xmlns:a="http://schemas.openxmlformats.org/drawingml/2006/main" xmlns:p="http://schemas.openxmlformats.org/presentationml/2006/main" xmlns:r="http://schemas.openxmlformats.org/officeDocument/2006/relationships">
   <p:cSld>
     <p:spTree>

</xml_diff>